<commit_message>
fix(presentation): align narrative to Phase 1 vs Phase 2 migration and update fine calculation to Rs 10/day
</commit_message>
<xml_diff>
--- a/VITCC_Library_Management_System_Presentation.pptx
+++ b/VITCC_Library_Management_System_Presentation.pptx
@@ -6958,7 +6958,7 @@
             <a:br/>
             <a:br/>
             <a:r>
-              <a:t>        -- Auto-calculate Rs. 5/day fine</a:t>
+              <a:t>        -- Auto-calculate Rs. 10/day fine</a:t>
             </a:r>
             <a:br/>
             <a:r>
@@ -6966,7 +6966,7 @@
             </a:r>
             <a:br/>
             <a:r>
-              <a:t>        SET fine_amount = r_ov.days_late * 5.0</a:t>
+              <a:t>        SET fine_amount = r_ov.days_late * 10.0</a:t>
             </a:r>
             <a:br/>
             <a:r>
@@ -12373,7 +12373,7 @@
                   <a:srgbClr val="1E40AF"/>
                 </a:solidFill>
               </a:rPr>
-              <a:t>Dual-Database Mastery
+              <a:t>Database Migration Mastery
 </a:t>
             </a:r>
             <a:r>
@@ -12382,7 +12382,7 @@
                   <a:srgbClr val="475569"/>
                 </a:solidFill>
               </a:rPr>
-              <a:t>Gained deep architectural expertise in bridging transactional relational schemas (Oracle 21c) with connected graph stores (Neo4j AuraDB).</a:t>
+              <a:t>Gained deep architectural expertise by successfully migrating a transactional relational schema (Oracle 21c) into a modern, highly-connected graph store (Neo4j AuraDB).</a:t>
             </a:r>
           </a:p>
           <a:p>
@@ -13140,7 +13140,7 @@
               </a:defRPr>
             </a:pPr>
             <a:r>
-              <a:t>• Dual-Database Engineering: Combines an enterprise Oracle 21c relational schema with a Neo4j AuraDB property graph.</a:t>
+              <a:t>• Phased Database Migration: Phase 1 utilized Oracle 21c for strict relational modeling, while Phase 2 (DA-3) completely migrated the backend to Neo4j AuraDB to unlock advanced graph traversals and recommendations.</a:t>
             </a:r>
           </a:p>
           <a:p>
@@ -13170,7 +13170,7 @@
               </a:defRPr>
             </a:pPr>
             <a:r>
-              <a:t>• Automated Circulation Rules: Real-time 3-book borrowing quota enforcement and daily Rs. 5/day overdue fine calculation.</a:t>
+              <a:t>• Automated Circulation Rules: Real-time 3-book borrowing quota enforcement and daily Rs. 10/day overdue fine calculation.</a:t>
             </a:r>
           </a:p>
           <a:p>
@@ -14209,21 +14209,6 @@
               </a:defRPr>
             </a:pPr>
             <a:r>
-              <a:t>• Oracle Client / cx_Oracle connector executing transaction-managed PL/SQL stored procedures.</a:t>
-            </a:r>
-          </a:p>
-          <a:p>
-            <a:pPr>
-              <a:spcBef>
-                <a:spcPts val="200"/>
-              </a:spcBef>
-              <a:defRPr sz="950">
-                <a:solidFill>
-                  <a:srgbClr val="1E293B"/>
-                </a:solidFill>
-              </a:defRPr>
-            </a:pPr>
-            <a:r>
               <a:t>• Dynamic patron privacy masking to anonymize fellow student loan requests on shared canvases.</a:t>
             </a:r>
           </a:p>
@@ -14360,7 +14345,7 @@
               </a:defRPr>
             </a:pPr>
             <a:r>
-              <a:t>Relational Database (Oracle) &amp; Property Graph (Neo4j)</a:t>
+              <a:t>Phase 1 (Legacy Oracle) &amp; Phase 2 (Live Neo4j Graph)</a:t>
             </a:r>
           </a:p>
         </p:txBody>
@@ -14941,7 +14926,7 @@
                   <a:srgbClr val="475569"/>
                 </a:solidFill>
               </a:rPr>
-              <a:t>Overdue book returns automatically generate a financial disciplinary record (Rs. 5 per overdue day).</a:t>
+              <a:t>Overdue book returns automatically generate a financial disciplinary record (Rs. 10 per overdue day).</a:t>
             </a:r>
           </a:p>
           <a:p>

</xml_diff>